<commit_message>
Update presentation slides and add executive summary
</commit_message>
<xml_diff>
--- a/reports/presentation-slides/Jerel_Velarde_Business_Presentation.pptx
+++ b/reports/presentation-slides/Jerel_Velarde_Business_Presentation.pptx
@@ -2030,7 +2030,7 @@
                 <a:ea typeface="Georgia" pitchFamily="34" charset="-122"/>
                 <a:cs typeface="Georgia" pitchFamily="34" charset="-120"/>
               </a:rPr>
-              <a:t>75%</a:t>
+              <a:t>~56%</a:t>
             </a:r>
             <a:endParaRPr lang="en-US" sz="3200" dirty="0"/>
           </a:p>
@@ -2370,7 +2370,7 @@
       </p:sp>
       <p:pic>
         <p:nvPicPr>
-          <p:cNvPr id="4" name="Image 0" descr="preencoded.png">    </p:cNvPr>
+          <p:cNvPr id="4" name="Image 0" descr="preencoded.png"/>
           <p:cNvPicPr>
             <a:picLocks noChangeAspect="1"/>
           </p:cNvPicPr>
@@ -2668,7 +2668,7 @@
       </p:sp>
       <p:pic>
         <p:nvPicPr>
-          <p:cNvPr id="4" name="Image 0" descr="preencoded.png">    </p:cNvPr>
+          <p:cNvPr id="4" name="Image 0" descr="preencoded.png"/>
           <p:cNvPicPr>
             <a:picLocks noChangeAspect="1"/>
           </p:cNvPicPr>
@@ -3307,7 +3307,7 @@
       </p:sp>
       <p:pic>
         <p:nvPicPr>
-          <p:cNvPr id="4" name="Image 0" descr="preencoded.png">    </p:cNvPr>
+          <p:cNvPr id="4" name="Image 0" descr="preencoded.png"/>
           <p:cNvPicPr>
             <a:picLocks noChangeAspect="1"/>
           </p:cNvPicPr>
@@ -3505,7 +3505,7 @@
       </p:sp>
       <p:pic>
         <p:nvPicPr>
-          <p:cNvPr id="4" name="Image 0" descr="preencoded.png">    </p:cNvPr>
+          <p:cNvPr id="4" name="Image 0" descr="preencoded.png"/>
           <p:cNvPicPr>
             <a:picLocks noChangeAspect="1"/>
           </p:cNvPicPr>
@@ -3787,7 +3787,7 @@
       </p:sp>
       <p:pic>
         <p:nvPicPr>
-          <p:cNvPr id="4" name="Image 0" descr="preencoded.png">    </p:cNvPr>
+          <p:cNvPr id="4" name="Image 0" descr="preencoded.png"/>
           <p:cNvPicPr>
             <a:picLocks noChangeAspect="1"/>
           </p:cNvPicPr>
@@ -3907,7 +3907,7 @@
                   <a:srgbClr val="44403C"/>
                 </a:solidFill>
               </a:rPr>
-              <a:t>AI salaries grew 15-20% year-over-year from 2020 to 2022</a:t>
+              <a:t>Dataset spans 2020–2022 with growing representation of remote and senior roles</a:t>
             </a:r>
             <a:endParaRPr lang="en-US" sz="1500" dirty="0"/>
           </a:p>

</xml_diff>